<commit_message>
docs: Add Task 6 slides with Campaign Details dashboard walkthrough, screenshots, approach, and learnings
</commit_message>
<xml_diff>
--- a/Kratika_MidReview_IndiaMART (1).pptx
+++ b/Kratika_MidReview_IndiaMART (1).pptx
@@ -21,6 +21,9 @@
     <p:sldId id="266" r:id="rId16"/>
     <p:sldId id="267" r:id="rId17"/>
     <p:sldId id="268" r:id="rId18"/>
+    <p:sldId id="272" r:id="rId27"/>
+    <p:sldId id="273" r:id="rId28"/>
+    <p:sldId id="274" r:id="rId29"/>
     <p:sldId id="269" r:id="rId19"/>
     <p:sldId id="270" r:id="rId20"/>
     <p:sldId id="271" r:id="rId21"/>
@@ -14396,6 +14399,804 @@
 </file>
 
 <file path=ppt/slides/slide16.xml><?xml version="1.0" encoding="utf-8"?>
+<p:sld xmlns:a="http://schemas.openxmlformats.org/drawingml/2006/main" xmlns:p="http://schemas.openxmlformats.org/presentationml/2006/main" xmlns:r="http://schemas.openxmlformats.org/officeDocument/2006/relationships">
+  <p:cSld>
+    <p:spTree>
+      <p:nvGrpSpPr>
+        <p:cNvPr id="1" name=""/>
+        <p:cNvGrpSpPr/>
+        <p:nvPr/>
+      </p:nvGrpSpPr>
+      <p:grpSpPr/>
+      <p:sp>
+        <p:nvSpPr>
+          <p:cNvPr id="2" name="TextBox 1"/>
+          <p:cNvSpPr txBox="1"/>
+          <p:nvPr/>
+        </p:nvSpPr>
+        <p:spPr>
+          <a:xfrm>
+            <a:off x="502920" y="256032"/>
+            <a:ext cx="6858000" cy="365760"/>
+          </a:xfrm>
+          <a:prstGeom prst="rect">
+            <a:avLst/>
+          </a:prstGeom>
+          <a:noFill/>
+        </p:spPr>
+        <p:txBody>
+          <a:bodyPr wrap="square" lIns="0" tIns="0">
+            <a:spAutoFit/>
+          </a:bodyPr>
+          <a:lstStyle/>
+          <a:p>
+            <a:pPr>
+              <a:defRPr sz="2000" b="1">
+                <a:solidFill>
+                  <a:srgbClr val="1C2F6B"/>
+                </a:solidFill>
+                <a:latin typeface="Calibri"/>
+              </a:defRPr>
+            </a:pPr>
+            <a:r>
+              <a:t>Task 6: Campaign Details Analytics Dashboard — Overview</a:t>
+            </a:r>
+          </a:p>
+        </p:txBody>
+      </p:sp>
+      <p:sp>
+        <p:nvSpPr>
+          <p:cNvPr id="3" name="TextBox 2"/>
+          <p:cNvSpPr txBox="1"/>
+          <p:nvPr/>
+        </p:nvSpPr>
+        <p:spPr>
+          <a:xfrm>
+            <a:off x="600000" y="1000000"/>
+            <a:ext cx="3400000" cy="3500000"/>
+          </a:xfrm>
+          <a:prstGeom prst="rect">
+            <a:avLst/>
+          </a:prstGeom>
+          <a:noFill/>
+        </p:spPr>
+        <p:txBody>
+          <a:bodyPr wrap="square">
+            <a:spAutoFit/>
+          </a:bodyPr>
+          <a:lstStyle/>
+          <a:p>
+            <a:pPr>
+              <a:spcAft>
+                <a:spcPts val="1500"/>
+              </a:spcAft>
+              <a:defRPr sz="1500" b="1">
+                <a:solidFill>
+                  <a:srgbClr val="1C2F6B"/>
+                </a:solidFill>
+                <a:latin typeface="Calibri"/>
+              </a:defRPr>
+            </a:pPr>
+            <a:r>
+              <a:t>Goal &amp; Scope</a:t>
+            </a:r>
+          </a:p>
+          <a:p>
+            <a:pPr>
+              <a:spcAft>
+                <a:spcPts val="1000"/>
+              </a:spcAft>
+            </a:pPr>
+            <a:r>
+              <a:rPr sz="1300" b="1">
+                <a:solidFill>
+                  <a:srgbClr val="333333"/>
+                </a:solidFill>
+                <a:latin typeface="Calibri"/>
+              </a:rPr>
+              <a:t>Automated Dashboard: </a:t>
+            </a:r>
+            <a:r>
+              <a:rPr sz="1300" b="0">
+                <a:solidFill>
+                  <a:srgbClr val="333333"/>
+                </a:solidFill>
+                <a:latin typeface="Calibri"/>
+              </a:rPr>
+              <a:t>Built interactive campaign details view with dynamic Daily, Weekly, and Monthly tracking options.</a:t>
+            </a:r>
+          </a:p>
+          <a:p>
+            <a:pPr>
+              <a:spcAft>
+                <a:spcPts val="1000"/>
+              </a:spcAft>
+            </a:pPr>
+            <a:r>
+              <a:rPr sz="1300" b="1">
+                <a:solidFill>
+                  <a:srgbClr val="333333"/>
+                </a:solidFill>
+                <a:latin typeface="Calibri"/>
+              </a:rPr>
+              <a:t>Granular Drilldown: </a:t>
+            </a:r>
+            <a:r>
+              <a:rPr sz="1300" b="0">
+                <a:solidFill>
+                  <a:srgbClr val="333333"/>
+                </a:solidFill>
+                <a:latin typeface="Calibri"/>
+              </a:rPr>
+              <a:t>Supports cascading Group → PMCAT → MCAT level selectors, resolving static report limits.</a:t>
+            </a:r>
+          </a:p>
+          <a:p>
+            <a:pPr>
+              <a:spcAft>
+                <a:spcPts val="1000"/>
+              </a:spcAft>
+            </a:pPr>
+            <a:r>
+              <a:rPr sz="1300" b="1">
+                <a:solidFill>
+                  <a:srgbClr val="333333"/>
+                </a:solidFill>
+                <a:latin typeface="Calibri"/>
+              </a:rPr>
+              <a:t>State Optimization: </a:t>
+            </a:r>
+            <a:r>
+              <a:rPr sz="1300" b="0">
+                <a:solidFill>
+                  <a:srgbClr val="333333"/>
+                </a:solidFill>
+                <a:latin typeface="Calibri"/>
+              </a:rPr>
+              <a:t>Redesigned frontend states to dynamically adapt metric headers, comparing counts, and visual components.</a:t>
+            </a:r>
+          </a:p>
+        </p:txBody>
+      </p:sp>
+      <p:sp>
+        <p:nvSpPr>
+          <p:cNvPr id="4" name="TextBox 3"/>
+          <p:cNvSpPr txBox="1"/>
+          <p:nvPr/>
+        </p:nvSpPr>
+        <p:spPr>
+          <a:xfrm>
+            <a:off x="4400000" y="1000000"/>
+            <a:ext cx="3400000" cy="3500000"/>
+          </a:xfrm>
+          <a:prstGeom prst="rect">
+            <a:avLst/>
+          </a:prstGeom>
+          <a:noFill/>
+        </p:spPr>
+        <p:txBody>
+          <a:bodyPr wrap="square">
+            <a:spAutoFit/>
+          </a:bodyPr>
+          <a:lstStyle/>
+          <a:p>
+            <a:pPr>
+              <a:spcAft>
+                <a:spcPts val="1500"/>
+              </a:spcAft>
+              <a:defRPr sz="1500" b="1">
+                <a:solidFill>
+                  <a:srgbClr val="1C2F6B"/>
+                </a:solidFill>
+                <a:latin typeface="Calibri"/>
+              </a:defRPr>
+            </a:pPr>
+            <a:r>
+              <a:t>Technical Approach</a:t>
+            </a:r>
+          </a:p>
+          <a:p>
+            <a:pPr>
+              <a:spcAft>
+                <a:spcPts val="1000"/>
+              </a:spcAft>
+            </a:pPr>
+            <a:r>
+              <a:rPr sz="1300" b="1">
+                <a:solidFill>
+                  <a:srgbClr val="333333"/>
+                </a:solidFill>
+                <a:latin typeface="Calibri"/>
+              </a:rPr>
+              <a:t>Redshift Integration: </a:t>
+            </a:r>
+            <a:r>
+              <a:rPr sz="1300" b="0">
+                <a:solidFill>
+                  <a:srgbClr val="333333"/>
+                </a:solidFill>
+                <a:latin typeface="Calibri"/>
+              </a:rPr>
+              <a:t>Connected Next.js endpoint to bi-dwh-redshift-production pool to run live SQL queries.</a:t>
+            </a:r>
+          </a:p>
+          <a:p>
+            <a:pPr>
+              <a:spcAft>
+                <a:spcPts val="1000"/>
+              </a:spcAft>
+            </a:pPr>
+            <a:r>
+              <a:rPr sz="1300" b="1">
+                <a:solidFill>
+                  <a:srgbClr val="333333"/>
+                </a:solidFill>
+                <a:latin typeface="Calibri"/>
+              </a:rPr>
+              <a:t>Dynamic Parameters: </a:t>
+            </a:r>
+            <a:r>
+              <a:rPr sz="1300" b="0">
+                <a:solidFill>
+                  <a:srgbClr val="333333"/>
+                </a:solidFill>
+                <a:latin typeface="Calibri"/>
+              </a:rPr>
+              <a:t>Configured API route to read search parameters and adapt queries dynamically based on selection.</a:t>
+            </a:r>
+          </a:p>
+          <a:p>
+            <a:pPr>
+              <a:spcAft>
+                <a:spcPts val="1000"/>
+              </a:spcAft>
+            </a:pPr>
+            <a:r>
+              <a:rPr sz="1300" b="1">
+                <a:solidFill>
+                  <a:srgbClr val="333333"/>
+                </a:solidFill>
+                <a:latin typeface="Calibri"/>
+              </a:rPr>
+              <a:t>Zero Google Sheets: </a:t>
+            </a:r>
+            <a:r>
+              <a:rPr sz="1300" b="0">
+                <a:solidFill>
+                  <a:srgbClr val="333333"/>
+                </a:solidFill>
+                <a:latin typeface="Calibri"/>
+              </a:rPr>
+              <a:t>Decoupled dashboard from slow, rate-limited sheets to fetch aggregated data directly from DWH.</a:t>
+            </a:r>
+          </a:p>
+        </p:txBody>
+      </p:sp>
+      <p:sp>
+        <p:nvSpPr>
+          <p:cNvPr id="5" name="TextBox 4"/>
+          <p:cNvSpPr txBox="1"/>
+          <p:nvPr/>
+        </p:nvSpPr>
+        <p:spPr>
+          <a:xfrm>
+            <a:off x="8200000" y="1000000"/>
+            <a:ext cx="3400000" cy="3500000"/>
+          </a:xfrm>
+          <a:prstGeom prst="rect">
+            <a:avLst/>
+          </a:prstGeom>
+          <a:noFill/>
+        </p:spPr>
+        <p:txBody>
+          <a:bodyPr wrap="square">
+            <a:spAutoFit/>
+          </a:bodyPr>
+          <a:lstStyle/>
+          <a:p>
+            <a:pPr>
+              <a:spcAft>
+                <a:spcPts val="1500"/>
+              </a:spcAft>
+              <a:defRPr sz="1500" b="1">
+                <a:solidFill>
+                  <a:srgbClr val="1C2F6B"/>
+                </a:solidFill>
+                <a:latin typeface="Calibri"/>
+              </a:defRPr>
+            </a:pPr>
+            <a:r>
+              <a:t>Key Learnings</a:t>
+            </a:r>
+          </a:p>
+          <a:p>
+            <a:pPr>
+              <a:spcAft>
+                <a:spcPts val="1000"/>
+              </a:spcAft>
+            </a:pPr>
+            <a:r>
+              <a:rPr sz="1300" b="1">
+                <a:solidFill>
+                  <a:srgbClr val="333333"/>
+                </a:solidFill>
+                <a:latin typeface="Calibri"/>
+              </a:rPr>
+              <a:t>Redshift Limitations: </a:t>
+            </a:r>
+            <a:r>
+              <a:rPr sz="1300" b="0">
+                <a:solidFill>
+                  <a:srgbClr val="333333"/>
+                </a:solidFill>
+                <a:latin typeface="Calibri"/>
+              </a:rPr>
+              <a:t>Discovered AWS Redshift constraints on month intervals, resolving it with day-based equivalents (365 days).</a:t>
+            </a:r>
+          </a:p>
+          <a:p>
+            <a:pPr>
+              <a:spcAft>
+                <a:spcPts val="1000"/>
+              </a:spcAft>
+            </a:pPr>
+            <a:r>
+              <a:rPr sz="1300" b="1">
+                <a:solidFill>
+                  <a:srgbClr val="333333"/>
+                </a:solidFill>
+                <a:latin typeface="Calibri"/>
+              </a:rPr>
+              <a:t>Scale Performance: </a:t>
+            </a:r>
+            <a:r>
+              <a:rPr sz="1300" b="0">
+                <a:solidFill>
+                  <a:srgbClr val="333333"/>
+                </a:solidFill>
+                <a:latin typeface="Calibri"/>
+              </a:rPr>
+              <a:t>Managed mapping logic for ~200K data rows on client state, optimizing parsing speeds and memory.</a:t>
+            </a:r>
+          </a:p>
+          <a:p>
+            <a:pPr>
+              <a:spcAft>
+                <a:spcPts val="1000"/>
+              </a:spcAft>
+            </a:pPr>
+            <a:r>
+              <a:rPr sz="1300" b="1">
+                <a:solidFill>
+                  <a:srgbClr val="333333"/>
+                </a:solidFill>
+                <a:latin typeface="Calibri"/>
+              </a:rPr>
+              <a:t>Data Inconsistencies: </a:t>
+            </a:r>
+            <a:r>
+              <a:rPr sz="1300" b="0">
+                <a:solidFill>
+                  <a:srgbClr val="333333"/>
+                </a:solidFill>
+                <a:latin typeface="Calibri"/>
+              </a:rPr>
+              <a:t>Learned to handle empty state checks across daily/monthly boundaries without breaking UI chart rendering.</a:t>
+            </a:r>
+          </a:p>
+        </p:txBody>
+      </p:sp>
+    </p:spTree>
+  </p:cSld>
+  <p:clrMapOvr>
+    <a:masterClrMapping/>
+  </p:clrMapOvr>
+</p:sld>
+</file>
+
+<file path=ppt/slides/slide17.xml><?xml version="1.0" encoding="utf-8"?>
+<p:sld xmlns:a="http://schemas.openxmlformats.org/drawingml/2006/main" xmlns:p="http://schemas.openxmlformats.org/presentationml/2006/main" xmlns:r="http://schemas.openxmlformats.org/officeDocument/2006/relationships">
+  <p:cSld>
+    <p:spTree>
+      <p:nvGrpSpPr>
+        <p:cNvPr id="1" name=""/>
+        <p:cNvGrpSpPr/>
+        <p:nvPr/>
+      </p:nvGrpSpPr>
+      <p:grpSpPr/>
+      <p:sp>
+        <p:nvSpPr>
+          <p:cNvPr id="2" name="TextBox 1"/>
+          <p:cNvSpPr txBox="1"/>
+          <p:nvPr/>
+        </p:nvSpPr>
+        <p:spPr>
+          <a:xfrm>
+            <a:off x="502920" y="256032"/>
+            <a:ext cx="6858000" cy="365760"/>
+          </a:xfrm>
+          <a:prstGeom prst="rect">
+            <a:avLst/>
+          </a:prstGeom>
+          <a:noFill/>
+        </p:spPr>
+        <p:txBody>
+          <a:bodyPr wrap="square" lIns="0" tIns="0">
+            <a:spAutoFit/>
+          </a:bodyPr>
+          <a:lstStyle/>
+          <a:p>
+            <a:pPr>
+              <a:defRPr sz="2000" b="1">
+                <a:solidFill>
+                  <a:srgbClr val="1C2F6B"/>
+                </a:solidFill>
+                <a:latin typeface="Calibri"/>
+              </a:defRPr>
+            </a:pPr>
+            <a:r>
+              <a:t>Task 6: Campaign Details — Standard View Dashboard</a:t>
+            </a:r>
+          </a:p>
+        </p:txBody>
+      </p:sp>
+      <p:pic>
+        <p:nvPicPr>
+          <p:cNvPr id="3" name="Picture 2" descr="media_89ae4b45-cd95-4dee-afa7-478ba11610c8_1779262978991.png"/>
+          <p:cNvPicPr>
+            <a:picLocks noChangeAspect="1"/>
+          </p:cNvPicPr>
+          <p:nvPr/>
+        </p:nvPicPr>
+        <p:blipFill>
+          <a:blip r:embed="rId2"/>
+          <a:stretch>
+            <a:fillRect/>
+          </a:stretch>
+        </p:blipFill>
+        <p:spPr>
+          <a:xfrm>
+            <a:off x="450000" y="1000000"/>
+            <a:ext cx="5400000" cy="3771297"/>
+          </a:xfrm>
+          <a:prstGeom prst="rect">
+            <a:avLst/>
+          </a:prstGeom>
+        </p:spPr>
+      </p:pic>
+      <p:sp>
+        <p:nvSpPr>
+          <p:cNvPr id="4" name="TextBox 3"/>
+          <p:cNvSpPr txBox="1"/>
+          <p:nvPr/>
+        </p:nvSpPr>
+        <p:spPr>
+          <a:xfrm>
+            <a:off x="6100000" y="1100000"/>
+            <a:ext cx="5600000" cy="3400000"/>
+          </a:xfrm>
+          <a:prstGeom prst="rect">
+            <a:avLst/>
+          </a:prstGeom>
+          <a:noFill/>
+        </p:spPr>
+        <p:txBody>
+          <a:bodyPr wrap="square">
+            <a:spAutoFit/>
+          </a:bodyPr>
+          <a:lstStyle/>
+          <a:p>
+            <a:pPr>
+              <a:spcAft>
+                <a:spcPts val="1000"/>
+              </a:spcAft>
+            </a:pPr>
+            <a:r>
+              <a:rPr sz="1300" b="1">
+                <a:solidFill>
+                  <a:srgbClr val="333333"/>
+                </a:solidFill>
+                <a:latin typeface="Calibri"/>
+              </a:rPr>
+              <a:t>Performance Header: </a:t>
+            </a:r>
+            <a:r>
+              <a:rPr sz="1300" b="0">
+                <a:solidFill>
+                  <a:srgbClr val="333333"/>
+                </a:solidFill>
+                <a:latin typeface="Calibri"/>
+              </a:rPr>
+              <a:t>Displays the selected MCAT name, reporting date, and the database feed status (Redshift DWH).</a:t>
+            </a:r>
+          </a:p>
+          <a:p>
+            <a:pPr>
+              <a:spcAft>
+                <a:spcPts val="1000"/>
+              </a:spcAft>
+            </a:pPr>
+            <a:r>
+              <a:rPr sz="1300" b="1">
+                <a:solidFill>
+                  <a:srgbClr val="333333"/>
+                </a:solidFill>
+                <a:latin typeface="Calibri"/>
+              </a:rPr>
+              <a:t>Attribution Metric Cards: </a:t>
+            </a:r>
+            <a:r>
+              <a:rPr sz="1300" b="0">
+                <a:solidFill>
+                  <a:srgbClr val="333333"/>
+                </a:solidFill>
+                <a:latin typeface="Calibri"/>
+              </a:rPr>
+              <a:t>Renders key indicators including impressions, clicks, CTR, cost, conversions, BL approved, BL sold, cost per txn, and diversity.</a:t>
+            </a:r>
+          </a:p>
+          <a:p>
+            <a:pPr>
+              <a:spcAft>
+                <a:spcPts val="1000"/>
+              </a:spcAft>
+            </a:pPr>
+            <a:r>
+              <a:rPr sz="1300" b="1">
+                <a:solidFill>
+                  <a:srgbClr val="333333"/>
+                </a:solidFill>
+                <a:latin typeface="Calibri"/>
+              </a:rPr>
+              <a:t>Ranking Analysis: </a:t>
+            </a:r>
+            <a:r>
+              <a:rPr sz="1300" b="0">
+                <a:solidFill>
+                  <a:srgbClr val="333333"/>
+                </a:solidFill>
+                <a:latin typeface="Calibri"/>
+              </a:rPr>
+              <a:t>Shows top/bottom 10 performers sorted by any metric dynamically (e.g. conversions or cost/txn) for optimization.</a:t>
+            </a:r>
+          </a:p>
+          <a:p>
+            <a:pPr>
+              <a:spcAft>
+                <a:spcPts val="1000"/>
+              </a:spcAft>
+            </a:pPr>
+            <a:r>
+              <a:rPr sz="1300" b="1">
+                <a:solidFill>
+                  <a:srgbClr val="333333"/>
+                </a:solidFill>
+                <a:latin typeface="Calibri"/>
+              </a:rPr>
+              <a:t>Historical Trend: </a:t>
+            </a:r>
+            <a:r>
+              <a:rPr sz="1300" b="0">
+                <a:solidFill>
+                  <a:srgbClr val="333333"/>
+                </a:solidFill>
+                <a:latin typeface="Calibri"/>
+              </a:rPr>
+              <a:t>Plots cost, clicks, and impressions over a 12-week, 30-day, or 12-month trend line.</a:t>
+            </a:r>
+          </a:p>
+        </p:txBody>
+      </p:sp>
+    </p:spTree>
+  </p:cSld>
+  <p:clrMapOvr>
+    <a:masterClrMapping/>
+  </p:clrMapOvr>
+</p:sld>
+</file>
+
+<file path=ppt/slides/slide18.xml><?xml version="1.0" encoding="utf-8"?>
+<p:sld xmlns:a="http://schemas.openxmlformats.org/drawingml/2006/main" xmlns:p="http://schemas.openxmlformats.org/presentationml/2006/main" xmlns:r="http://schemas.openxmlformats.org/officeDocument/2006/relationships">
+  <p:cSld>
+    <p:spTree>
+      <p:nvGrpSpPr>
+        <p:cNvPr id="1" name=""/>
+        <p:cNvGrpSpPr/>
+        <p:nvPr/>
+      </p:nvGrpSpPr>
+      <p:grpSpPr/>
+      <p:sp>
+        <p:nvSpPr>
+          <p:cNvPr id="2" name="TextBox 1"/>
+          <p:cNvSpPr txBox="1"/>
+          <p:nvPr/>
+        </p:nvSpPr>
+        <p:spPr>
+          <a:xfrm>
+            <a:off x="502920" y="256032"/>
+            <a:ext cx="6858000" cy="365760"/>
+          </a:xfrm>
+          <a:prstGeom prst="rect">
+            <a:avLst/>
+          </a:prstGeom>
+          <a:noFill/>
+        </p:spPr>
+        <p:txBody>
+          <a:bodyPr wrap="square" lIns="0" tIns="0">
+            <a:spAutoFit/>
+          </a:bodyPr>
+          <a:lstStyle/>
+          <a:p>
+            <a:pPr>
+              <a:defRPr sz="2000" b="1">
+                <a:solidFill>
+                  <a:srgbClr val="1C2F6B"/>
+                </a:solidFill>
+                <a:latin typeface="Calibri"/>
+              </a:defRPr>
+            </a:pPr>
+            <a:r>
+              <a:t>Task 6: Campaign Details — Compare Mode &amp; AI Insights</a:t>
+            </a:r>
+          </a:p>
+        </p:txBody>
+      </p:sp>
+      <p:pic>
+        <p:nvPicPr>
+          <p:cNvPr id="3" name="Picture 2" descr="media_89ae4b45-cd95-4dee-afa7-478ba11610c8_1779262982935.png"/>
+          <p:cNvPicPr>
+            <a:picLocks noChangeAspect="1"/>
+          </p:cNvPicPr>
+          <p:nvPr/>
+        </p:nvPicPr>
+        <p:blipFill>
+          <a:blip r:embed="rId2"/>
+          <a:stretch>
+            <a:fillRect/>
+          </a:stretch>
+        </p:blipFill>
+        <p:spPr>
+          <a:xfrm>
+            <a:off x="450000" y="1000000"/>
+            <a:ext cx="5400000" cy="3771297"/>
+          </a:xfrm>
+          <a:prstGeom prst="rect">
+            <a:avLst/>
+          </a:prstGeom>
+        </p:spPr>
+      </p:pic>
+      <p:sp>
+        <p:nvSpPr>
+          <p:cNvPr id="4" name="TextBox 3"/>
+          <p:cNvSpPr txBox="1"/>
+          <p:nvPr/>
+        </p:nvSpPr>
+        <p:spPr>
+          <a:xfrm>
+            <a:off x="6100000" y="1100000"/>
+            <a:ext cx="5600000" cy="3400000"/>
+          </a:xfrm>
+          <a:prstGeom prst="rect">
+            <a:avLst/>
+          </a:prstGeom>
+          <a:noFill/>
+        </p:spPr>
+        <p:txBody>
+          <a:bodyPr wrap="square">
+            <a:spAutoFit/>
+          </a:bodyPr>
+          <a:lstStyle/>
+          <a:p>
+            <a:pPr>
+              <a:spcAft>
+                <a:spcPts val="1000"/>
+              </a:spcAft>
+            </a:pPr>
+            <a:r>
+              <a:rPr sz="1300" b="1">
+                <a:solidFill>
+                  <a:srgbClr val="333333"/>
+                </a:solidFill>
+                <a:latin typeface="Calibri"/>
+              </a:rPr>
+              <a:t>Best Ever KPIs Banner: </a:t>
+            </a:r>
+            <a:r>
+              <a:rPr sz="1300" b="0">
+                <a:solidFill>
+                  <a:srgbClr val="333333"/>
+                </a:solidFill>
+                <a:latin typeface="Calibri"/>
+              </a:rPr>
+              <a:t>Highlights historic peak performance indicators across the compared periods for comparison benchmarks.</a:t>
+            </a:r>
+          </a:p>
+          <a:p>
+            <a:pPr>
+              <a:spcAft>
+                <a:spcPts val="1000"/>
+              </a:spcAft>
+            </a:pPr>
+            <a:r>
+              <a:rPr sz="1300" b="1">
+                <a:solidFill>
+                  <a:srgbClr val="333333"/>
+                </a:solidFill>
+                <a:latin typeface="Calibri"/>
+              </a:rPr>
+              <a:t>AI-Generated Insights: </a:t>
+            </a:r>
+            <a:r>
+              <a:rPr sz="1300" b="0">
+                <a:solidFill>
+                  <a:srgbClr val="333333"/>
+                </a:solidFill>
+                <a:latin typeface="Calibri"/>
+              </a:rPr>
+              <a:t>Dynamically generates textual alerts on budget overspends, cost-per-transaction anomalies, and bidding advice.</a:t>
+            </a:r>
+          </a:p>
+          <a:p>
+            <a:pPr>
+              <a:spcAft>
+                <a:spcPts val="1000"/>
+              </a:spcAft>
+            </a:pPr>
+            <a:r>
+              <a:rPr sz="1300" b="1">
+                <a:solidFill>
+                  <a:srgbClr val="333333"/>
+                </a:solidFill>
+                <a:latin typeface="Calibri"/>
+              </a:rPr>
+              <a:t>Metric Comparison Table: </a:t>
+            </a:r>
+            <a:r>
+              <a:rPr sz="1300" b="0">
+                <a:solidFill>
+                  <a:srgbClr val="333333"/>
+                </a:solidFill>
+                <a:latin typeface="Calibri"/>
+              </a:rPr>
+              <a:t>Provides grid breakdown of each metric across compared weeks/days/months to track percentage improvements.</a:t>
+            </a:r>
+          </a:p>
+          <a:p>
+            <a:pPr>
+              <a:spcAft>
+                <a:spcPts val="1000"/>
+              </a:spcAft>
+            </a:pPr>
+            <a:r>
+              <a:rPr sz="1300" b="1">
+                <a:solidFill>
+                  <a:srgbClr val="333333"/>
+                </a:solidFill>
+                <a:latin typeface="Calibri"/>
+              </a:rPr>
+              <a:t>Cascading Selectors: </a:t>
+            </a:r>
+            <a:r>
+              <a:rPr sz="1300" b="0">
+                <a:solidFill>
+                  <a:srgbClr val="333333"/>
+                </a:solidFill>
+                <a:latin typeface="Calibri"/>
+              </a:rPr>
+              <a:t>Interactive filters allow side-by-side comparison of specific groups, PMCATs, or individual MCAT campaigns.</a:t>
+            </a:r>
+          </a:p>
+        </p:txBody>
+      </p:sp>
+    </p:spTree>
+  </p:cSld>
+  <p:clrMapOvr>
+    <a:masterClrMapping/>
+  </p:clrMapOvr>
+</p:sld>
+</file>
+
+<file path=ppt/slides/slide19.xml><?xml version="1.0" encoding="utf-8"?>
 <p:sld xmlns:a="http://schemas.openxmlformats.org/drawingml/2006/main" xmlns:r="http://schemas.openxmlformats.org/officeDocument/2006/relationships" xmlns:mc="http://schemas.openxmlformats.org/markup-compatibility/2006" xmlns:mv="urn:schemas-microsoft-com:mac:vml" xmlns:p="http://schemas.openxmlformats.org/presentationml/2006/main" xmlns:c="http://schemas.openxmlformats.org/drawingml/2006/chart" xmlns:dgm="http://schemas.openxmlformats.org/drawingml/2006/diagram" xmlns:o="urn:schemas-microsoft-com:office:office" xmlns:v="urn:schemas-microsoft-com:vml" xmlns:pvml="urn:schemas-microsoft-com:office:powerpoint" xmlns:com="http://schemas.openxmlformats.org/drawingml/2006/compatibility" xmlns:p14="http://schemas.microsoft.com/office/powerpoint/2010/main" xmlns:p15="http://schemas.microsoft.com/office/powerpoint/2012/main" xmlns:ahyp="http://schemas.microsoft.com/office/drawing/2018/hyperlinkcolor">
   <p:cSld>
     <p:spTree>

</xml_diff>